<commit_message>
feat: amplia missao cibersegura no DF
</commit_message>
<xml_diff>
--- a/presentation/pcdf-missao-cibersegura-banca.pptx
+++ b/presentation/pcdf-missao-cibersegura-banca.pptx
@@ -2,24 +2,24 @@
 <file path=ppt/presentation.xml><?xml version="1.0" encoding="utf-8"?>
 <p:presentation xmlns:p="http://schemas.openxmlformats.org/presentationml/2006/main">
   <p:sldMasterIdLst>
-    <p:sldMasterId xmlns:r="http://schemas.openxmlformats.org/officeDocument/2006/relationships" id="2147483648" r:id="R286ac005b2da4042"/>
+    <p:sldMasterId xmlns:r="http://schemas.openxmlformats.org/officeDocument/2006/relationships" id="2147483648" r:id="R7ad39dcce89f4b53"/>
   </p:sldMasterIdLst>
   <p:notesMasterIdLst>
-    <p:notesMasterId xmlns:r="http://schemas.openxmlformats.org/officeDocument/2006/relationships" r:id="Rb3d7142aba404961"/>
+    <p:notesMasterId xmlns:r="http://schemas.openxmlformats.org/officeDocument/2006/relationships" r:id="R232a799d00b24954"/>
   </p:notesMasterIdLst>
   <p:sldIdLst>
-    <p:sldId xmlns:r="http://schemas.openxmlformats.org/officeDocument/2006/relationships" id="256" r:id="R7770bf7a25f0466e"/>
-    <p:sldId xmlns:r="http://schemas.openxmlformats.org/officeDocument/2006/relationships" id="257" r:id="Raaa04c21fe7941dd"/>
-    <p:sldId xmlns:r="http://schemas.openxmlformats.org/officeDocument/2006/relationships" id="258" r:id="R4616fce2aa97454d"/>
-    <p:sldId xmlns:r="http://schemas.openxmlformats.org/officeDocument/2006/relationships" id="259" r:id="R981ec96c54984842"/>
-    <p:sldId xmlns:r="http://schemas.openxmlformats.org/officeDocument/2006/relationships" id="260" r:id="Rf5b343f94bb14f15"/>
-    <p:sldId xmlns:r="http://schemas.openxmlformats.org/officeDocument/2006/relationships" id="261" r:id="Rcdc5f310cf904681"/>
-    <p:sldId xmlns:r="http://schemas.openxmlformats.org/officeDocument/2006/relationships" id="262" r:id="R988109a9ee754274"/>
-    <p:sldId xmlns:r="http://schemas.openxmlformats.org/officeDocument/2006/relationships" id="263" r:id="R395b7f03b4714942"/>
-    <p:sldId xmlns:r="http://schemas.openxmlformats.org/officeDocument/2006/relationships" id="264" r:id="R63207fe768d442f8"/>
-    <p:sldId xmlns:r="http://schemas.openxmlformats.org/officeDocument/2006/relationships" id="265" r:id="R4def7e8c55f14a02"/>
-    <p:sldId xmlns:r="http://schemas.openxmlformats.org/officeDocument/2006/relationships" id="266" r:id="Rd1b9c18cd8e347d8"/>
-    <p:sldId xmlns:r="http://schemas.openxmlformats.org/officeDocument/2006/relationships" id="267" r:id="R9144b61773fd4d6d"/>
+    <p:sldId xmlns:r="http://schemas.openxmlformats.org/officeDocument/2006/relationships" id="256" r:id="R35467ec82c364136"/>
+    <p:sldId xmlns:r="http://schemas.openxmlformats.org/officeDocument/2006/relationships" id="257" r:id="R3fd3ac3803ae4967"/>
+    <p:sldId xmlns:r="http://schemas.openxmlformats.org/officeDocument/2006/relationships" id="258" r:id="R1f1610ed79eb47b8"/>
+    <p:sldId xmlns:r="http://schemas.openxmlformats.org/officeDocument/2006/relationships" id="259" r:id="Ra143a1c8dba54406"/>
+    <p:sldId xmlns:r="http://schemas.openxmlformats.org/officeDocument/2006/relationships" id="260" r:id="R0917337386e945eb"/>
+    <p:sldId xmlns:r="http://schemas.openxmlformats.org/officeDocument/2006/relationships" id="261" r:id="R029a419e5b1c4c2c"/>
+    <p:sldId xmlns:r="http://schemas.openxmlformats.org/officeDocument/2006/relationships" id="262" r:id="Rad7a00846624487d"/>
+    <p:sldId xmlns:r="http://schemas.openxmlformats.org/officeDocument/2006/relationships" id="263" r:id="R05279556b9444c98"/>
+    <p:sldId xmlns:r="http://schemas.openxmlformats.org/officeDocument/2006/relationships" id="264" r:id="R565b063a60f54dbb"/>
+    <p:sldId xmlns:r="http://schemas.openxmlformats.org/officeDocument/2006/relationships" id="265" r:id="Rdf0b97f2964d4999"/>
+    <p:sldId xmlns:r="http://schemas.openxmlformats.org/officeDocument/2006/relationships" id="266" r:id="Ra53dcbeaa4354221"/>
+    <p:sldId xmlns:r="http://schemas.openxmlformats.org/officeDocument/2006/relationships" id="267" r:id="R8e9c1a758aed45f9"/>
   </p:sldIdLst>
   <p:sldSz cx="12192000" cy="6858000"/>
   <p:notesSz cx="6858000" cy="9144000"/>
@@ -1338,7 +1338,7 @@
   </p:cSld>
   <p:clrMap bg1="lt1" tx1="dk1" bg2="lt2" tx2="dk2" accent1="accent1" accent2="accent2" accent3="accent3" accent4="accent4" accent5="accent5" accent6="accent6" hlink="hlink" folHlink="folHlink"/>
   <p:sldLayoutIdLst>
-    <p:sldLayoutId xmlns:r="http://schemas.openxmlformats.org/officeDocument/2006/relationships" id="2147483649" r:id="Ra734952bafb74c57"/>
+    <p:sldLayoutId xmlns:r="http://schemas.openxmlformats.org/officeDocument/2006/relationships" id="2147483649" r:id="R51ae50909aec4a48"/>
   </p:sldLayoutIdLst>
   <p:txStyles>
     <p:titleStyle>
@@ -1893,16 +1893,13 @@
           <p:nvPr/>
         </p:nvPicPr>
         <p:blipFill>
-          <a:blip xmlns:r="http://schemas.openxmlformats.org/officeDocument/2006/relationships" xmlns:a="http://schemas.openxmlformats.org/drawingml/2006/main" r:embed="R1c7216f74ce14b97"/>
-          <a:srcRect xmlns:a="http://schemas.openxmlformats.org/drawingml/2006/main" l="25391" t="0" r="25391" b="0"/>
-          <a:stretch xmlns:a="http://schemas.openxmlformats.org/drawingml/2006/main">
-            <a:fillRect l="0" t="0" r="0" b="0"/>
-          </a:stretch>
+          <a:blip xmlns:r="http://schemas.openxmlformats.org/officeDocument/2006/relationships" xmlns:a="http://schemas.openxmlformats.org/drawingml/2006/main" r:embed="R1c2fb38c9fdf4491"/>
+          <a:stretch xmlns:a="http://schemas.openxmlformats.org/drawingml/2006/main"/>
         </p:blipFill>
         <p:spPr>
           <a:xfrm xmlns:a="http://schemas.openxmlformats.org/drawingml/2006/main">
-            <a:off x="6191250" y="0"/>
-            <a:ext cx="6000750" cy="6858000"/>
+            <a:off x="6191250" y="1741289"/>
+            <a:ext cx="6000750" cy="3375422"/>
           </a:xfrm>
           <a:prstGeom xmlns:a="http://schemas.openxmlformats.org/drawingml/2006/main" prst="rect">
             <a:avLst/>
@@ -6768,7 +6765,7 @@
                 <a:ea typeface="Aptos"/>
                 <a:cs typeface="Aptos"/>
               </a:rPr>
-              <a:t>sete categorias</a:t>
+              <a:t>quinze categorias</a:t>
             </a:r>
           </a:p>
         </p:txBody>
@@ -9018,7 +9015,7 @@
                 <a:ea typeface="Aptos"/>
                 <a:cs typeface="Aptos"/>
               </a:rPr>
-              <a:t>Brasilia cartunesca</a:t>
+              <a:t>5 fases do DF</a:t>
             </a:r>
           </a:p>
         </p:txBody>
@@ -10191,7 +10188,7 @@
                 <a:ea typeface="Aptos Display"/>
                 <a:cs typeface="Aptos Display"/>
               </a:rPr>
-              <a:t>Meta: investigar 12 ocorrencias, ler cada orientacao e chegar - sintese final.</a:t>
+              <a:t>Meta: investigar 20 ocorrencias, ler cada orientacao e chegar - sintese final.</a:t>
             </a:r>
           </a:p>
         </p:txBody>
@@ -10448,7 +10445,7 @@
                 <a:ea typeface="Aptos Display"/>
                 <a:cs typeface="Aptos Display"/>
               </a:rPr>
-              <a:t>Sete categorias - uma linguagem visual por risco</a:t>
+              <a:t>15 categorias em grupos visuais de risco</a:t>
             </a:r>
           </a:p>
         </p:txBody>
@@ -10505,7 +10502,7 @@
                 <a:ea typeface="Aptos"/>
                 <a:cs typeface="Aptos"/>
               </a:rPr>
-              <a:t>Cada encontro ensina reconhecimento, prevencao e preservacao de evidencias.</a:t>
+              <a:t>Cada encontro ensina reconhecimento, prevencao, preservacao de evidencias e pedido de ajuda.</a:t>
             </a:r>
           </a:p>
         </p:txBody>
@@ -10758,7 +10755,7 @@
                 <a:ea typeface="Aptos Display"/>
                 <a:cs typeface="Aptos Display"/>
               </a:rPr>
-              <a:t>MALWARE</a:t>
+              <a:t>MALWARE / WI-FI</a:t>
             </a:r>
           </a:p>
         </p:txBody>
@@ -10815,7 +10812,7 @@
                 <a:ea typeface="Aptos"/>
                 <a:cs typeface="Aptos"/>
               </a:rPr>
-              <a:t>arquivo - atualizacao</a:t>
+              <a:t>arquivo - rede falsa</a:t>
             </a:r>
           </a:p>
         </p:txBody>
@@ -10913,7 +10910,7 @@
                 <a:ea typeface="Aptos Display"/>
                 <a:cs typeface="Aptos Display"/>
               </a:rPr>
-              <a:t>PERFIL FALSO</a:t>
+              <a:t>PERFIL/ALICIAMENTO</a:t>
             </a:r>
           </a:p>
         </p:txBody>
@@ -10970,7 +10967,7 @@
                 <a:ea typeface="Aptos"/>
                 <a:cs typeface="Aptos"/>
               </a:rPr>
-              <a:t>verificar por outro canal</a:t>
+              <a:t>identidade - adulto</a:t>
             </a:r>
           </a:p>
         </p:txBody>
@@ -11068,7 +11065,7 @@
                 <a:ea typeface="Aptos Display"/>
                 <a:cs typeface="Aptos Display"/>
               </a:rPr>
-              <a:t>RANSOMWARE</a:t>
+              <a:t>RANSOMWARE / DADOS</a:t>
             </a:r>
           </a:p>
         </p:txBody>
@@ -11125,7 +11122,7 @@
                 <a:ea typeface="Aptos"/>
                 <a:cs typeface="Aptos"/>
               </a:rPr>
-              <a:t>backup - isolar</a:t>
+              <a:t>backup - dados</a:t>
             </a:r>
           </a:p>
         </p:txBody>
@@ -11223,7 +11220,7 @@
                 <a:ea typeface="Aptos Display"/>
                 <a:cs typeface="Aptos Display"/>
               </a:rPr>
-              <a:t>PAGAMENTO / QR</a:t>
+              <a:t>PAGAMENTO / LOJA</a:t>
             </a:r>
           </a:p>
         </p:txBody>
@@ -11280,7 +11277,7 @@
                 <a:ea typeface="Aptos"/>
                 <a:cs typeface="Aptos"/>
               </a:rPr>
-              <a:t>destinatario - pressao</a:t>
+              <a:t>destinatario - reputacao</a:t>
             </a:r>
           </a:p>
         </p:txBody>
@@ -11378,7 +11375,7 @@
                 <a:ea typeface="Aptos Display"/>
                 <a:cs typeface="Aptos Display"/>
               </a:rPr>
-              <a:t>VIOLENCIA DIGITAL</a:t>
+              <a:t>VIOLENCIA/DOXXING</a:t>
             </a:r>
           </a:p>
         </p:txBody>
@@ -11435,7 +11432,7 @@
                 <a:ea typeface="Aptos"/>
                 <a:cs typeface="Aptos"/>
               </a:rPr>
-              <a:t>bloquear - apoio</a:t>
+              <a:t>bloquear - provas</a:t>
             </a:r>
           </a:p>
         </p:txBody>
@@ -11533,7 +11530,7 @@
                 <a:ea typeface="Aptos Display"/>
                 <a:cs typeface="Aptos Display"/>
               </a:rPr>
-              <a:t>INVASAO DE CONTA</a:t>
+              <a:t>CONTA / SUPORTE / IA</a:t>
             </a:r>
           </a:p>
         </p:txBody>
@@ -11590,7 +11587,7 @@
                 <a:ea typeface="Aptos"/>
                 <a:cs typeface="Aptos"/>
               </a:rPr>
-              <a:t>senha - 2 etapas</a:t>
+              <a:t>senha - confirmar origem</a:t>
             </a:r>
           </a:p>
         </p:txBody>
@@ -11918,7 +11915,7 @@
           <p:nvPr/>
         </p:nvPicPr>
         <p:blipFill>
-          <a:blip xmlns:r="http://schemas.openxmlformats.org/officeDocument/2006/relationships" xmlns:a="http://schemas.openxmlformats.org/drawingml/2006/main" r:embed="R8627bbe304f343e1"/>
+          <a:blip xmlns:r="http://schemas.openxmlformats.org/officeDocument/2006/relationships" xmlns:a="http://schemas.openxmlformats.org/drawingml/2006/main" r:embed="Rfbda39c0bc6e4294"/>
           <a:stretch xmlns:a="http://schemas.openxmlformats.org/drawingml/2006/main"/>
         </p:blipFill>
         <p:spPr>
@@ -11926,7 +11923,7 @@
             <a:off x="686858" y="1952625"/>
             <a:ext cx="8094133" cy="4552950"/>
           </a:xfrm>
-          <a:prstGeom xmlns:a="http://schemas.openxmlformats.org/drawingml/2006/main" prst="roundRect">
+          <a:prstGeom xmlns:a="http://schemas.openxmlformats.org/drawingml/2006/main" prst="rect">
             <a:avLst/>
           </a:prstGeom>
         </p:spPr>
@@ -12105,7 +12102,8 @@
                 <a:ea typeface="Aptos"/>
                 <a:cs typeface="Aptos"/>
               </a:rPr>
-              <a:t>Progresso 0/12</a:t>
+              <a:t>Fase atual
+Progresso 0/20</a:t>
             </a:r>
           </a:p>
           <a:p xmlns:a="http://schemas.openxmlformats.org/drawingml/2006/main">
@@ -12129,7 +12127,7 @@
                 <a:ea typeface="Aptos"/>
                 <a:cs typeface="Aptos"/>
               </a:rPr>
-              <a:t>Controles persistentes</a:t>
+              <a:t/>
             </a:r>
           </a:p>
         </p:txBody>
@@ -12284,7 +12282,7 @@
                 <a:ea typeface="Aptos"/>
                 <a:cs typeface="Aptos"/>
               </a:rPr>
-              <a:t>Base Ciber</a:t>
+              <a:t>Congresso e Lago</a:t>
             </a:r>
           </a:p>
           <a:p xmlns:a="http://schemas.openxmlformats.org/drawingml/2006/main">
@@ -12308,7 +12306,7 @@
                 <a:ea typeface="Aptos"/>
                 <a:cs typeface="Aptos"/>
               </a:rPr>
-              <a:t>Ipes e escola</a:t>
+              <a:t>Ipes, nuvens e fases</a:t>
             </a:r>
           </a:p>
           <a:p xmlns:a="http://schemas.openxmlformats.org/drawingml/2006/main">
@@ -17738,7 +17736,7 @@
                 <a:ea typeface="Aptos Display"/>
                 <a:cs typeface="Aptos Display"/>
               </a:rPr>
-              <a:t>12</a:t>
+              <a:t>20</a:t>
             </a:r>
           </a:p>
         </p:txBody>
@@ -17893,7 +17891,7 @@
                 <a:ea typeface="Aptos Display"/>
                 <a:cs typeface="Aptos Display"/>
               </a:rPr>
-              <a:t>7</a:t>
+              <a:t>15</a:t>
             </a:r>
           </a:p>
         </p:txBody>
@@ -18415,7 +18413,7 @@
                 <a:ea typeface="Aptos Display"/>
                 <a:cs typeface="Aptos Display"/>
               </a:rPr>
-              <a:t>Tilemap 120x22 - ate 12 ameacas - primitivas 2D - save &lt; 10 KB - rede zero no desktop</a:t>
+              <a:t>Tilemap 210x22 - ate 20 ameacas - primitivas 2D - save &lt; 20 KB - rede zero no desktop</a:t>
             </a:r>
           </a:p>
         </p:txBody>

</xml_diff>